<commit_message>
Use FDR<0.05 throughout: rerun notebook v2 and update deck
Co-Authored-By: Claude Sonnet 5.5 <noreply@anthropic.com>
Claude-Session: https://claude.ai/code/session_01MDTqECGuBCmCmnrEyk4wDi
</commit_message>
<xml_diff>
--- a/omics_element_lmm/deck/elements_proteome_deck.pptx
+++ b/omics_element_lmm/deck/elements_proteome_deck.pptx
@@ -120,14 +120,14 @@
   <p:extLst>
     <p:ext uri="{521415D9-36F7-43E2-AB2F-B90AF26B5E84}">
       <p14:sectionLst xmlns:p14="http://schemas.microsoft.com/office/powerpoint/2010/main">
-        <p14:section name="Intro" id="{c75c555f-3a99-59d1-9971-32dfca3c9ca6}">
+        <p14:section name="Intro" id="{e0402679-8b46-eb2e-52bc-680cb122b3a9}">
           <p14:sldIdLst>
             <p14:sldId id="256"/>
             <p14:sldId id="257"/>
             <p14:sldId id="258"/>
           </p14:sldIdLst>
         </p14:section>
-        <p14:section name="Elements" id="{28fb60cd-556d-18e0-85a7-95fb10b32e72}">
+        <p14:section name="Elements" id="{e030f993-ce67-45d3-c817-7ea88a7654f3}">
           <p14:sldIdLst>
             <p14:sldId id="259"/>
             <p14:sldId id="260"/>
@@ -136,24 +136,24 @@
             <p14:sldId id="263"/>
           </p14:sldIdLst>
         </p14:section>
-        <p14:section name="Held-out animals" id="{8843b982-2177-ffba-cfd1-22e8aaea14b4}">
+        <p14:section name="Held-out animals" id="{5d98af47-4db5-c3e7-87f2-e168b689bb84}">
           <p14:sldIdLst>
             <p14:sldId id="264"/>
           </p14:sldIdLst>
         </p14:section>
-        <p14:section name="Ratios" id="{00d70909-6f21-3f4f-c101-d628e87ef860}">
+        <p14:section name="Ratios" id="{8028507c-9ce5-e406-e840-9f0271076f2e}">
           <p14:sldIdLst>
             <p14:sldId id="265"/>
             <p14:sldId id="266"/>
           </p14:sldIdLst>
         </p14:section>
-        <p14:section name="Known proteins" id="{c8d8990c-01f0-9e67-6564-9f50f8b96736}">
+        <p14:section name="Known proteins" id="{f74f7546-e863-8db2-7720-833a555d32ba}">
           <p14:sldIdLst>
             <p14:sldId id="267"/>
             <p14:sldId id="268"/>
           </p14:sldIdLst>
         </p14:section>
-        <p14:section name="Close" id="{5398e42a-7cba-3405-b11c-066db2647e34}">
+        <p14:section name="Close" id="{802922e1-ed8e-63ec-b41f-e15be6b96bbe}">
           <p14:sldIdLst>
             <p14:sldId id="269"/>
           </p14:sldIdLst>
@@ -193,7 +193,7 @@
                 </a:solidFill>
                 <a:latin typeface="+mn-lt"/>
               </a:rPr>
-              <a:t>Proteins at FDR &lt; 0.10</a:t>
+              <a:t>Proteins at FDR &lt; 0.05</a:t>
             </a:r>
           </a:p>
         </c:rich>
@@ -300,7 +300,7 @@
                   <c:v>3</c:v>
                 </c:pt>
                 <c:pt idx="2">
-                  <c:v>11</c:v>
+                  <c:v>3</c:v>
                 </c:pt>
                 <c:pt idx="3">
                   <c:v>0</c:v>
@@ -407,28 +407,28 @@
                 <c:formatCode>General</c:formatCode>
                 <c:ptCount val="8"/>
                 <c:pt idx="0">
-                  <c:v>356</c:v>
+                  <c:v>75</c:v>
                 </c:pt>
                 <c:pt idx="1">
-                  <c:v>123</c:v>
+                  <c:v>21</c:v>
                 </c:pt>
                 <c:pt idx="2">
-                  <c:v>18</c:v>
+                  <c:v>2</c:v>
                 </c:pt>
                 <c:pt idx="3">
-                  <c:v>172</c:v>
+                  <c:v>41</c:v>
                 </c:pt>
                 <c:pt idx="4">
-                  <c:v>348</c:v>
+                  <c:v>62</c:v>
                 </c:pt>
                 <c:pt idx="5">
-                  <c:v>106</c:v>
+                  <c:v>23</c:v>
                 </c:pt>
                 <c:pt idx="6">
-                  <c:v>169</c:v>
+                  <c:v>28</c:v>
                 </c:pt>
                 <c:pt idx="7">
-                  <c:v>146</c:v>
+                  <c:v>29</c:v>
                 </c:pt>
               </c:numCache>
             </c:numRef>
@@ -2867,7 +2867,7 @@
                   <a:schemeClr val="tx2"/>
                 </a:solidFill>
               </a:rPr>
-              <a:t>Fe/Cu is the one ratio with a clear protein signal</a:t>
+              <a:t>Ca/Mg is the only ratio with FDR-significant proteins, all driven by Mg</a:t>
             </a:r>
             <a:endParaRPr lang="en-US" sz="2800" dirty="0"/>
           </a:p>
@@ -2875,7 +2875,7 @@
       </p:sp>
       <p:pic>
         <p:nvPicPr>
-          <p:cNvPr id="3" name="Image 0" descr="img/rt_FeCu.png">    </p:cNvPr>
+          <p:cNvPr id="3" name="Image 0" descr="img/rt_CaMg.png">    </p:cNvPr>
           <p:cNvPicPr>
             <a:picLocks noChangeAspect="1"/>
           </p:cNvPicPr>
@@ -2957,7 +2957,7 @@
                 <a:ea typeface="Cambria" pitchFamily="34" charset="-122"/>
                 <a:cs typeface="Cambria" pitchFamily="34" charset="-120"/>
               </a:rPr>
-              <a:t>27</a:t>
+              <a:t>95</a:t>
             </a:r>
             <a:endParaRPr lang="en-US" sz="4000" dirty="0"/>
           </a:p>
@@ -2993,7 +2993,7 @@
                   <a:schemeClr val="tx1"/>
                 </a:solidFill>
               </a:rPr>
-              <a:t>proteins at FDR&lt;0.10 for Fe/Cu</a:t>
+              <a:t>proteins at FDR&lt;0.05 for Ca/Mg (Mg alone: 3)</a:t>
             </a:r>
             <a:endParaRPr lang="en-US" sz="1400" dirty="0"/>
           </a:p>
@@ -3059,7 +3059,7 @@
                 <a:ea typeface="Cambria" pitchFamily="34" charset="-122"/>
                 <a:cs typeface="Cambria" pitchFamily="34" charset="-120"/>
               </a:rPr>
-              <a:t>60</a:t>
+              <a:t>196</a:t>
             </a:r>
             <a:endParaRPr lang="en-US" sz="4000" dirty="0"/>
           </a:p>
@@ -3161,7 +3161,7 @@
                 <a:ea typeface="Cambria" pitchFamily="34" charset="-122"/>
                 <a:cs typeface="Cambria" pitchFamily="34" charset="-120"/>
               </a:rPr>
-              <a:t>490</a:t>
+              <a:t>0</a:t>
             </a:r>
             <a:endParaRPr lang="en-US" sz="4000" dirty="0"/>
           </a:p>
@@ -3197,7 +3197,7 @@
                   <a:schemeClr val="tx1"/>
                 </a:solidFill>
               </a:rPr>
-              <a:t>for Ca/Mg, which just mirrors Mg</a:t>
+              <a:t>proteins at FDR&lt;0.05 for Fe/Cu (60 at p&lt;0.001)</a:t>
             </a:r>
             <a:endParaRPr lang="en-US" sz="1400" dirty="0"/>
           </a:p>
@@ -12488,7 +12488,7 @@
                   <a:schemeClr val="tx1"/>
                 </a:solidFill>
               </a:rPr>
-              <a:t>Validate Cu with acute-phase markers and Fe/Cu in new samples</a:t>
+              <a:t>Validate the Cu acute-phase link in new samples</a:t>
             </a:r>
             <a:endParaRPr lang="en-US" sz="1600" dirty="0"/>
           </a:p>
@@ -13523,7 +13523,7 @@
                 <a:ea typeface="Cambria" pitchFamily="34" charset="-122"/>
                 <a:cs typeface="Cambria" pitchFamily="34" charset="-120"/>
               </a:rPr>
-              <a:t>Viral load dominates</a:t>
+              <a:t>Viral load outweighs the elements</a:t>
             </a:r>
             <a:endParaRPr lang="en-US" sz="2400" dirty="0"/>
           </a:p>
@@ -13559,7 +13559,7 @@
                   <a:schemeClr val="tx1"/>
                 </a:solidFill>
               </a:rPr>
-              <a:t>106-356 proteins pass FDR&lt;0.10 for viral load; at most 11 do for any element</a:t>
+              <a:t>2-75 proteins pass FDR&lt;0.05 for viral load; at most 3 do for any element (Mg, P). P is the one exception</a:t>
             </a:r>
             <a:endParaRPr lang="en-US" sz="1700" dirty="0"/>
           </a:p>
@@ -14221,7 +14221,7 @@
                   <a:schemeClr val="tx2"/>
                 </a:solidFill>
               </a:rPr>
-              <a:t>Mg: few proteins pass FDR, but far more than chance reach p&lt;0.001</a:t>
+              <a:t>Mg: 3 proteins pass FDR&lt;0.05, far more than chance reach p&lt;0.001</a:t>
             </a:r>
             <a:endParaRPr lang="en-US" sz="2800" dirty="0"/>
           </a:p>
@@ -14347,7 +14347,7 @@
                   <a:schemeClr val="tx1"/>
                 </a:solidFill>
               </a:rPr>
-              <a:t>proteins at FDR&lt;0.10 (element)</a:t>
+              <a:t>proteins at FDR&lt;0.05 (element)</a:t>
             </a:r>
             <a:endParaRPr lang="en-US" sz="1400" dirty="0"/>
           </a:p>
@@ -14515,7 +14515,7 @@
                 <a:ea typeface="Cambria" pitchFamily="34" charset="-122"/>
                 <a:cs typeface="Cambria" pitchFamily="34" charset="-120"/>
               </a:rPr>
-              <a:t>123</a:t>
+              <a:t>21</a:t>
             </a:r>
             <a:endParaRPr lang="en-US" sz="4000" dirty="0"/>
           </a:p>
@@ -14551,7 +14551,7 @@
                   <a:schemeClr val="tx1"/>
                 </a:solidFill>
               </a:rPr>
-              <a:t>proteins at FDR&lt;0.10 (viral load)</a:t>
+              <a:t>proteins at FDR&lt;0.05 (viral load)</a:t>
             </a:r>
             <a:endParaRPr lang="en-US" sz="1400" dirty="0"/>
           </a:p>
@@ -14659,7 +14659,7 @@
                   <a:schemeClr val="tx2"/>
                 </a:solidFill>
               </a:rPr>
-              <a:t>Cu: 37 proteins at p&lt;0.001, none at FDR&lt;0.10</a:t>
+              <a:t>Cu: 37 proteins at p&lt;0.001, none at FDR&lt;0.05</a:t>
             </a:r>
             <a:endParaRPr lang="en-US" sz="2800" dirty="0"/>
           </a:p>
@@ -14785,7 +14785,7 @@
                   <a:schemeClr val="tx1"/>
                 </a:solidFill>
               </a:rPr>
-              <a:t>proteins at FDR&lt;0.10 (element)</a:t>
+              <a:t>proteins at FDR&lt;0.05 (element)</a:t>
             </a:r>
             <a:endParaRPr lang="en-US" sz="1400" dirty="0"/>
           </a:p>
@@ -14953,7 +14953,7 @@
                 <a:ea typeface="Cambria" pitchFamily="34" charset="-122"/>
                 <a:cs typeface="Cambria" pitchFamily="34" charset="-120"/>
               </a:rPr>
-              <a:t>169</a:t>
+              <a:t>28</a:t>
             </a:r>
             <a:endParaRPr lang="en-US" sz="4000" dirty="0"/>
           </a:p>
@@ -14989,7 +14989,7 @@
                   <a:schemeClr val="tx1"/>
                 </a:solidFill>
               </a:rPr>
-              <a:t>proteins at FDR&lt;0.10 (viral load)</a:t>
+              <a:t>proteins at FDR&lt;0.05 (viral load)</a:t>
             </a:r>
             <a:endParaRPr lang="en-US" sz="1400" dirty="0"/>
           </a:p>
@@ -15223,7 +15223,7 @@
                   <a:schemeClr val="tx1"/>
                 </a:solidFill>
               </a:rPr>
-              <a:t>proteins at FDR&lt;0.10 (element)</a:t>
+              <a:t>proteins at FDR&lt;0.05 (element)</a:t>
             </a:r>
             <a:endParaRPr lang="en-US" sz="1400" dirty="0"/>
           </a:p>
@@ -15391,7 +15391,7 @@
                 <a:ea typeface="Cambria" pitchFamily="34" charset="-122"/>
                 <a:cs typeface="Cambria" pitchFamily="34" charset="-120"/>
               </a:rPr>
-              <a:t>106</a:t>
+              <a:t>23</a:t>
             </a:r>
             <a:endParaRPr lang="en-US" sz="4000" dirty="0"/>
           </a:p>
@@ -15427,7 +15427,7 @@
                   <a:schemeClr val="tx1"/>
                 </a:solidFill>
               </a:rPr>
-              <a:t>proteins at FDR&lt;0.10 (viral load)</a:t>
+              <a:t>proteins at FDR&lt;0.05 (viral load)</a:t>
             </a:r>
             <a:endParaRPr lang="en-US" sz="1400" dirty="0"/>
           </a:p>
@@ -15535,7 +15535,7 @@
                   <a:schemeClr val="tx2"/>
                 </a:solidFill>
               </a:rPr>
-              <a:t>Viral load, not the element, drives the proteome</a:t>
+              <a:t>Viral load outweighs the elements in the proteome</a:t>
             </a:r>
             <a:endParaRPr lang="en-US" sz="2800" dirty="0"/>
           </a:p>
@@ -15591,7 +15591,25 @@
                   <a:schemeClr val="tx1"/>
                 </a:solidFill>
               </a:rPr>
-              <a:t>No protein passes FDR&lt;0.10 for both an element and viral load</a:t>
+              <a:t>No protein passes FDR&lt;0.05 for both an element and viral load</a:t>
+            </a:r>
+            <a:endParaRPr lang="en-US" sz="1600" dirty="0"/>
+          </a:p>
+          <a:p>
+            <a:pPr marL="342900" indent="-342900">
+              <a:spcAft>
+                <a:spcPts val="1000"/>
+              </a:spcAft>
+              <a:buSzPct val="100000"/>
+              <a:buChar char="•"/>
+            </a:pPr>
+            <a:r>
+              <a:rPr lang="en-US" sz="1600" dirty="0">
+                <a:solidFill>
+                  <a:schemeClr val="tx1"/>
+                </a:solidFill>
+              </a:rPr>
+              <a:t>P is the exception: 3 element hits vs 2 for viral load</a:t>
             </a:r>
             <a:endParaRPr lang="en-US" sz="1600" dirty="0"/>
           </a:p>

</xml_diff>